<commit_message>
Fixed typos in next word prediction and added presentation for thinking in geometry
</commit_message>
<xml_diff>
--- a/Day4/markov/next_word_prediction.pptx
+++ b/Day4/markov/next_word_prediction.pptx
@@ -3206,14 +3206,14 @@
           <a:p>
             <a:r>
               <a:rPr lang="en-US"/>
-              <a:t>Do the know what they are doing ?</a:t>
+              <a:t>Do they know what they are doing ?</a:t>
             </a:r>
             <a:endParaRPr lang="en-US"/>
           </a:p>
           <a:p>
             <a:r>
               <a:rPr lang="en-US"/>
-              <a:t>How do LLMs that power inteligenet agents work ?</a:t>
+              <a:t>How do LLMs that power intelligent agents work ?</a:t>
             </a:r>
             <a:endParaRPr lang="en-US"/>
           </a:p>
@@ -3230,7 +3230,7 @@
           <a:p>
             <a:r>
               <a:rPr lang="en-US"/>
-              <a:t>We’ll use a markov matrix as a tool / proxy to gain an intution about how LLMs work</a:t>
+              <a:t>We’ll use a markov matrix as a tool / proxy to gain an intuition about how LLMs work</a:t>
             </a:r>
             <a:endParaRPr lang="en-US"/>
           </a:p>
@@ -4328,10 +4328,6 @@
                       <a:pPr>
                         <a:buNone/>
                       </a:pPr>
-                      <a:r>
-                        <a:rPr lang="en-US"/>
-                        <a:t>1</a:t>
-                      </a:r>
                       <a:endParaRPr lang="en-US"/>
                     </a:p>
                   </a:txBody>
@@ -4416,10 +4412,6 @@
                       <a:pPr>
                         <a:buNone/>
                       </a:pPr>
-                      <a:r>
-                        <a:rPr lang="en-US"/>
-                        <a:t>2</a:t>
-                      </a:r>
                       <a:endParaRPr lang="en-US"/>
                     </a:p>
                   </a:txBody>
@@ -4432,10 +4424,6 @@
                       <a:pPr>
                         <a:buNone/>
                       </a:pPr>
-                      <a:r>
-                        <a:rPr lang="en-US"/>
-                        <a:t>1</a:t>
-                      </a:r>
                       <a:endParaRPr lang="en-US"/>
                     </a:p>
                   </a:txBody>
@@ -4484,10 +4472,6 @@
                       <a:pPr>
                         <a:buNone/>
                       </a:pPr>
-                      <a:r>
-                        <a:rPr lang="en-US"/>
-                        <a:t>1</a:t>
-                      </a:r>
                       <a:endParaRPr lang="en-US"/>
                     </a:p>
                   </a:txBody>
@@ -4560,10 +4544,6 @@
                       <a:pPr>
                         <a:buNone/>
                       </a:pPr>
-                      <a:r>
-                        <a:rPr lang="en-US"/>
-                        <a:t>1</a:t>
-                      </a:r>
                       <a:endParaRPr lang="en-US"/>
                     </a:p>
                   </a:txBody>
@@ -4765,10 +4745,6 @@
                       <a:pPr>
                         <a:buNone/>
                       </a:pPr>
-                      <a:r>
-                        <a:rPr lang="en-US"/>
-                        <a:t>1</a:t>
-                      </a:r>
                       <a:endParaRPr lang="en-US"/>
                     </a:p>
                   </a:txBody>
@@ -4853,10 +4829,6 @@
                       <a:pPr>
                         <a:buNone/>
                       </a:pPr>
-                      <a:r>
-                        <a:rPr lang="en-US"/>
-                        <a:t>0.66</a:t>
-                      </a:r>
                       <a:endParaRPr lang="en-US"/>
                     </a:p>
                   </a:txBody>
@@ -4869,10 +4841,6 @@
                       <a:pPr>
                         <a:buNone/>
                       </a:pPr>
-                      <a:r>
-                        <a:rPr lang="en-US"/>
-                        <a:t>0.33</a:t>
-                      </a:r>
                       <a:endParaRPr lang="en-US"/>
                     </a:p>
                   </a:txBody>
@@ -4921,10 +4889,6 @@
                       <a:pPr>
                         <a:buNone/>
                       </a:pPr>
-                      <a:r>
-                        <a:rPr lang="en-US"/>
-                        <a:t>1</a:t>
-                      </a:r>
                       <a:endParaRPr lang="en-US"/>
                     </a:p>
                   </a:txBody>
@@ -4997,10 +4961,6 @@
                       <a:pPr>
                         <a:buNone/>
                       </a:pPr>
-                      <a:r>
-                        <a:rPr lang="en-US"/>
-                        <a:t>1</a:t>
-                      </a:r>
                       <a:endParaRPr lang="en-US"/>
                     </a:p>
                   </a:txBody>

</xml_diff>